<commit_message>
fix: Update architecture figures for improved clarity and accuracy
</commit_message>
<xml_diff>
--- a/paper/2026-03/figures/fig1_architecture.pptx
+++ b/paper/2026-03/figures/fig1_architecture.pptx
@@ -302,7 +302,7 @@
           <a:p>
             <a:fld id="{5BCAD085-E8A6-8845-BD4E-CB4CCA059FC4}" type="datetimeFigureOut">
               <a:rPr lang="en-US" smtClean="0"/>
-              <a:t>3/4/2026</a:t>
+              <a:t>3/5/2026</a:t>
             </a:fld>
             <a:endParaRPr lang="en-US"/>
           </a:p>
@@ -470,7 +470,7 @@
           <a:p>
             <a:fld id="{5BCAD085-E8A6-8845-BD4E-CB4CCA059FC4}" type="datetimeFigureOut">
               <a:rPr lang="en-US" smtClean="0"/>
-              <a:t>3/4/2026</a:t>
+              <a:t>3/5/2026</a:t>
             </a:fld>
             <a:endParaRPr lang="en-US"/>
           </a:p>
@@ -648,7 +648,7 @@
           <a:p>
             <a:fld id="{5BCAD085-E8A6-8845-BD4E-CB4CCA059FC4}" type="datetimeFigureOut">
               <a:rPr lang="en-US" smtClean="0"/>
-              <a:t>3/4/2026</a:t>
+              <a:t>3/5/2026</a:t>
             </a:fld>
             <a:endParaRPr lang="en-US"/>
           </a:p>
@@ -816,7 +816,7 @@
           <a:p>
             <a:fld id="{5BCAD085-E8A6-8845-BD4E-CB4CCA059FC4}" type="datetimeFigureOut">
               <a:rPr lang="en-US" smtClean="0"/>
-              <a:t>3/4/2026</a:t>
+              <a:t>3/5/2026</a:t>
             </a:fld>
             <a:endParaRPr lang="en-US"/>
           </a:p>
@@ -1061,7 +1061,7 @@
           <a:p>
             <a:fld id="{5BCAD085-E8A6-8845-BD4E-CB4CCA059FC4}" type="datetimeFigureOut">
               <a:rPr lang="en-US" smtClean="0"/>
-              <a:t>3/4/2026</a:t>
+              <a:t>3/5/2026</a:t>
             </a:fld>
             <a:endParaRPr lang="en-US"/>
           </a:p>
@@ -1346,7 +1346,7 @@
           <a:p>
             <a:fld id="{5BCAD085-E8A6-8845-BD4E-CB4CCA059FC4}" type="datetimeFigureOut">
               <a:rPr lang="en-US" smtClean="0"/>
-              <a:t>3/4/2026</a:t>
+              <a:t>3/5/2026</a:t>
             </a:fld>
             <a:endParaRPr lang="en-US"/>
           </a:p>
@@ -1765,7 +1765,7 @@
           <a:p>
             <a:fld id="{5BCAD085-E8A6-8845-BD4E-CB4CCA059FC4}" type="datetimeFigureOut">
               <a:rPr lang="en-US" smtClean="0"/>
-              <a:t>3/4/2026</a:t>
+              <a:t>3/5/2026</a:t>
             </a:fld>
             <a:endParaRPr lang="en-US"/>
           </a:p>
@@ -1882,7 +1882,7 @@
           <a:p>
             <a:fld id="{5BCAD085-E8A6-8845-BD4E-CB4CCA059FC4}" type="datetimeFigureOut">
               <a:rPr lang="en-US" smtClean="0"/>
-              <a:t>3/4/2026</a:t>
+              <a:t>3/5/2026</a:t>
             </a:fld>
             <a:endParaRPr lang="en-US"/>
           </a:p>
@@ -1977,7 +1977,7 @@
           <a:p>
             <a:fld id="{5BCAD085-E8A6-8845-BD4E-CB4CCA059FC4}" type="datetimeFigureOut">
               <a:rPr lang="en-US" smtClean="0"/>
-              <a:t>3/4/2026</a:t>
+              <a:t>3/5/2026</a:t>
             </a:fld>
             <a:endParaRPr lang="en-US"/>
           </a:p>
@@ -2252,7 +2252,7 @@
           <a:p>
             <a:fld id="{5BCAD085-E8A6-8845-BD4E-CB4CCA059FC4}" type="datetimeFigureOut">
               <a:rPr lang="en-US" smtClean="0"/>
-              <a:t>3/4/2026</a:t>
+              <a:t>3/5/2026</a:t>
             </a:fld>
             <a:endParaRPr lang="en-US"/>
           </a:p>
@@ -2504,7 +2504,7 @@
           <a:p>
             <a:fld id="{5BCAD085-E8A6-8845-BD4E-CB4CCA059FC4}" type="datetimeFigureOut">
               <a:rPr lang="en-US" smtClean="0"/>
-              <a:t>3/4/2026</a:t>
+              <a:t>3/5/2026</a:t>
             </a:fld>
             <a:endParaRPr lang="en-US"/>
           </a:p>
@@ -2715,7 +2715,7 @@
           <a:p>
             <a:fld id="{5BCAD085-E8A6-8845-BD4E-CB4CCA059FC4}" type="datetimeFigureOut">
               <a:rPr lang="en-US" smtClean="0"/>
-              <a:t>3/4/2026</a:t>
+              <a:t>3/5/2026</a:t>
             </a:fld>
             <a:endParaRPr lang="en-US"/>
           </a:p>
@@ -3092,10 +3092,10 @@
       </p:grpSpPr>
       <p:grpSp>
         <p:nvGrpSpPr>
-          <p:cNvPr id="186" name="グループ化 185">
+          <p:cNvPr id="60" name="グループ化 59">
             <a:extLst>
               <a:ext uri="{FF2B5EF4-FFF2-40B4-BE49-F238E27FC236}">
-                <a16:creationId xmlns:a16="http://schemas.microsoft.com/office/drawing/2014/main" id="{EE4C3D34-E602-27F0-9C32-AEE786D20C9C}"/>
+                <a16:creationId xmlns:a16="http://schemas.microsoft.com/office/drawing/2014/main" id="{7F4AE20E-9709-358B-FA8C-2F5EA9FACB1F}"/>
               </a:ext>
             </a:extLst>
           </p:cNvPr>
@@ -3106,7 +3106,7 @@
           <a:xfrm>
             <a:off x="277586" y="420360"/>
             <a:ext cx="11585359" cy="2455823"/>
-            <a:chOff x="277586" y="595578"/>
+            <a:chOff x="277586" y="420360"/>
             <a:chExt cx="11585359" cy="2455823"/>
           </a:xfrm>
         </p:grpSpPr>
@@ -3118,7 +3118,7 @@
           </p:nvSpPr>
           <p:spPr>
             <a:xfrm>
-              <a:off x="1649321" y="614633"/>
+              <a:off x="1649321" y="439415"/>
               <a:ext cx="3474978" cy="2436768"/>
             </a:xfrm>
             <a:prstGeom prst="roundRect">
@@ -3166,7 +3166,7 @@
           </p:nvSpPr>
           <p:spPr>
             <a:xfrm>
-              <a:off x="2168392" y="595578"/>
+              <a:off x="2168392" y="420360"/>
               <a:ext cx="2772234" cy="400110"/>
             </a:xfrm>
             <a:prstGeom prst="rect">
@@ -3200,7 +3200,7 @@
           </p:nvSpPr>
           <p:spPr>
             <a:xfrm>
-              <a:off x="7574152" y="614632"/>
+              <a:off x="7574152" y="439414"/>
               <a:ext cx="2307398" cy="2305011"/>
             </a:xfrm>
             <a:prstGeom prst="roundRect">
@@ -3248,7 +3248,7 @@
           </p:nvSpPr>
           <p:spPr>
             <a:xfrm>
-              <a:off x="7547306" y="695715"/>
+              <a:off x="7547306" y="520497"/>
               <a:ext cx="2409186" cy="400110"/>
             </a:xfrm>
             <a:prstGeom prst="rect">
@@ -3282,7 +3282,7 @@
           </p:nvSpPr>
           <p:spPr>
             <a:xfrm>
-              <a:off x="9976642" y="614631"/>
+              <a:off x="9976642" y="439413"/>
               <a:ext cx="1886303" cy="2436769"/>
             </a:xfrm>
             <a:prstGeom prst="roundRect">
@@ -3330,7 +3330,7 @@
           </p:nvSpPr>
           <p:spPr>
             <a:xfrm>
-              <a:off x="10094161" y="608040"/>
+              <a:off x="10094161" y="432822"/>
               <a:ext cx="1664238" cy="400110"/>
             </a:xfrm>
             <a:prstGeom prst="rect">
@@ -3370,7 +3370,7 @@
           </p:nvGrpSpPr>
           <p:grpSpPr>
             <a:xfrm>
-              <a:off x="277586" y="1514678"/>
+              <a:off x="277586" y="1339460"/>
               <a:ext cx="1257423" cy="762171"/>
               <a:chOff x="0" y="2286514"/>
               <a:chExt cx="1257423" cy="762171"/>
@@ -3456,8 +3456,8 @@
               </a:p>
             </p:txBody>
           </p:sp>
-          <mc:AlternateContent xmlns:mc="http://schemas.openxmlformats.org/markup-compatibility/2006">
-            <mc:Choice xmlns:a14="http://schemas.microsoft.com/office/drawing/2010/main" Requires="a14">
+          <mc:AlternateContent xmlns:mc="http://schemas.openxmlformats.org/markup-compatibility/2006" xmlns:a14="http://schemas.microsoft.com/office/drawing/2010/main">
+            <mc:Choice Requires="a14">
               <p:sp>
                 <p:nvSpPr>
                   <p:cNvPr id="10" name="TextBox 9"/>
@@ -3576,7 +3576,7 @@
                 </p:txBody>
               </p:sp>
             </mc:Choice>
-            <mc:Fallback>
+            <mc:Fallback xmlns="">
               <p:sp>
                 <p:nvSpPr>
                   <p:cNvPr id="10" name="TextBox 9"/>
@@ -3624,7 +3624,7 @@
           </p:nvSpPr>
           <p:spPr>
             <a:xfrm>
-              <a:off x="1763632" y="1038694"/>
+              <a:off x="1763632" y="863476"/>
               <a:ext cx="1653028" cy="770628"/>
             </a:xfrm>
             <a:prstGeom prst="roundRect">
@@ -3670,7 +3670,7 @@
           </p:nvSpPr>
           <p:spPr>
             <a:xfrm>
-              <a:off x="1738983" y="1068033"/>
+              <a:off x="1738983" y="892815"/>
               <a:ext cx="1698478" cy="400110"/>
             </a:xfrm>
             <a:prstGeom prst="rect">
@@ -3706,7 +3706,7 @@
               </p:nvSpPr>
               <p:spPr>
                 <a:xfrm>
-                  <a:off x="1994896" y="1366765"/>
+                  <a:off x="1994896" y="1191547"/>
                   <a:ext cx="1374351" cy="442365"/>
                 </a:xfrm>
                 <a:prstGeom prst="rect">
@@ -3838,7 +3838,7 @@
               </p:nvSpPr>
               <p:spPr>
                 <a:xfrm>
-                  <a:off x="1994896" y="1366765"/>
+                  <a:off x="1994896" y="1191547"/>
                   <a:ext cx="1374351" cy="442365"/>
                 </a:xfrm>
                 <a:prstGeom prst="rect">
@@ -3874,7 +3874,7 @@
           </p:nvSpPr>
           <p:spPr>
             <a:xfrm>
-              <a:off x="1763632" y="2158457"/>
+              <a:off x="1763632" y="1983239"/>
               <a:ext cx="1668943" cy="786209"/>
             </a:xfrm>
             <a:prstGeom prst="roundRect">
@@ -3920,7 +3920,7 @@
           </p:nvSpPr>
           <p:spPr>
             <a:xfrm>
-              <a:off x="1762941" y="2193139"/>
+              <a:off x="1762941" y="2017921"/>
               <a:ext cx="1725729" cy="400110"/>
             </a:xfrm>
             <a:prstGeom prst="rect">
@@ -3956,7 +3956,7 @@
               </p:nvSpPr>
               <p:spPr>
                 <a:xfrm>
-                  <a:off x="1815721" y="2507789"/>
+                  <a:off x="1815721" y="2332571"/>
                   <a:ext cx="1618007" cy="428515"/>
                 </a:xfrm>
                 <a:prstGeom prst="rect">
@@ -4088,7 +4088,7 @@
               </p:nvSpPr>
               <p:spPr>
                 <a:xfrm>
-                  <a:off x="1815721" y="2507789"/>
+                  <a:off x="1815721" y="2332571"/>
                   <a:ext cx="1618007" cy="428515"/>
                 </a:xfrm>
                 <a:prstGeom prst="rect">
@@ -4124,7 +4124,7 @@
           </p:nvSpPr>
           <p:spPr>
             <a:xfrm>
-              <a:off x="3608864" y="1038694"/>
+              <a:off x="3608864" y="863476"/>
               <a:ext cx="1445008" cy="768599"/>
             </a:xfrm>
             <a:prstGeom prst="roundRect">
@@ -4170,7 +4170,7 @@
           </p:nvSpPr>
           <p:spPr>
             <a:xfrm>
-              <a:off x="3911224" y="1041606"/>
+              <a:off x="3911224" y="866388"/>
               <a:ext cx="960519" cy="400110"/>
             </a:xfrm>
             <a:prstGeom prst="rect">
@@ -4219,7 +4219,7 @@
               </p:nvSpPr>
               <p:spPr>
                 <a:xfrm>
-                  <a:off x="3608331" y="1365018"/>
+                  <a:off x="3608331" y="1189800"/>
                   <a:ext cx="1502190" cy="442365"/>
                 </a:xfrm>
                 <a:prstGeom prst="rect">
@@ -4351,7 +4351,7 @@
               </p:nvSpPr>
               <p:spPr>
                 <a:xfrm>
-                  <a:off x="3608331" y="1365018"/>
+                  <a:off x="3608331" y="1189800"/>
                   <a:ext cx="1502190" cy="442365"/>
                 </a:xfrm>
                 <a:prstGeom prst="rect">
@@ -4387,7 +4387,7 @@
           </p:nvSpPr>
           <p:spPr>
             <a:xfrm>
-              <a:off x="3632999" y="2156417"/>
+              <a:off x="3632999" y="1981199"/>
               <a:ext cx="1381395" cy="788249"/>
             </a:xfrm>
             <a:prstGeom prst="roundRect">
@@ -4433,7 +4433,7 @@
           </p:nvSpPr>
           <p:spPr>
             <a:xfrm>
-              <a:off x="3916243" y="2079048"/>
+              <a:off x="3916243" y="1903830"/>
               <a:ext cx="732315" cy="400110"/>
             </a:xfrm>
             <a:prstGeom prst="rect">
@@ -4482,7 +4482,7 @@
               </p:nvSpPr>
               <p:spPr>
                 <a:xfrm>
-                  <a:off x="3637008" y="2503551"/>
+                  <a:off x="3637008" y="2328333"/>
                   <a:ext cx="1419235" cy="428515"/>
                 </a:xfrm>
                 <a:prstGeom prst="rect">
@@ -4614,7 +4614,7 @@
               </p:nvSpPr>
               <p:spPr>
                 <a:xfrm>
-                  <a:off x="3637008" y="2503551"/>
+                  <a:off x="3637008" y="2328333"/>
                   <a:ext cx="1419235" cy="428515"/>
                 </a:xfrm>
                 <a:prstGeom prst="rect">
@@ -4650,7 +4650,7 @@
           </p:nvSpPr>
           <p:spPr>
             <a:xfrm>
-              <a:off x="7823687" y="1696680"/>
+              <a:off x="7823687" y="1521462"/>
               <a:ext cx="1981395" cy="896569"/>
             </a:xfrm>
             <a:prstGeom prst="roundRect">
@@ -4698,7 +4698,7 @@
           </p:nvSpPr>
           <p:spPr>
             <a:xfrm>
-              <a:off x="7724654" y="1556327"/>
+              <a:off x="7724654" y="1381109"/>
               <a:ext cx="1981395" cy="896568"/>
             </a:xfrm>
             <a:prstGeom prst="roundRect">
@@ -4746,7 +4746,7 @@
           </p:nvSpPr>
           <p:spPr>
             <a:xfrm>
-              <a:off x="7642584" y="1394331"/>
+              <a:off x="7642584" y="1219113"/>
               <a:ext cx="1981395" cy="918895"/>
             </a:xfrm>
             <a:prstGeom prst="roundRect">
@@ -4792,7 +4792,7 @@
           </p:nvSpPr>
           <p:spPr>
             <a:xfrm>
-              <a:off x="8176350" y="1389138"/>
+              <a:off x="8176350" y="1213920"/>
               <a:ext cx="895117" cy="400110"/>
             </a:xfrm>
             <a:prstGeom prst="rect">
@@ -4826,7 +4826,7 @@
           </p:nvSpPr>
           <p:spPr>
             <a:xfrm>
-              <a:off x="7687082" y="1640655"/>
+              <a:off x="7687082" y="1465437"/>
               <a:ext cx="1873654" cy="400110"/>
             </a:xfrm>
             <a:prstGeom prst="rect">
@@ -4860,7 +4860,7 @@
           </p:nvSpPr>
           <p:spPr>
             <a:xfrm>
-              <a:off x="8330398" y="1876928"/>
+              <a:off x="8330398" y="1701710"/>
               <a:ext cx="587020" cy="400110"/>
             </a:xfrm>
             <a:prstGeom prst="rect">
@@ -4894,7 +4894,7 @@
           </p:nvSpPr>
           <p:spPr>
             <a:xfrm>
-              <a:off x="8099774" y="980098"/>
+              <a:off x="8099774" y="804880"/>
               <a:ext cx="1163075" cy="400110"/>
             </a:xfrm>
             <a:prstGeom prst="rect">
@@ -4928,7 +4928,7 @@
           </p:nvSpPr>
           <p:spPr>
             <a:xfrm>
-              <a:off x="10090953" y="977258"/>
+              <a:off x="10090953" y="802040"/>
               <a:ext cx="1653803" cy="579069"/>
             </a:xfrm>
             <a:prstGeom prst="roundRect">
@@ -4974,7 +4974,7 @@
           </p:nvSpPr>
           <p:spPr>
             <a:xfrm>
-              <a:off x="10279613" y="961445"/>
+              <a:off x="10279613" y="786227"/>
               <a:ext cx="1351652" cy="400110"/>
             </a:xfrm>
             <a:prstGeom prst="rect">
@@ -5008,7 +5008,7 @@
           </p:nvSpPr>
           <p:spPr>
             <a:xfrm>
-              <a:off x="10286153" y="1187192"/>
+              <a:off x="10286153" y="1011974"/>
               <a:ext cx="1338573" cy="400110"/>
             </a:xfrm>
             <a:prstGeom prst="rect">
@@ -5042,7 +5042,7 @@
           </p:nvSpPr>
           <p:spPr>
             <a:xfrm>
-              <a:off x="10098574" y="1654824"/>
+              <a:off x="10098574" y="1479606"/>
               <a:ext cx="1653803" cy="538315"/>
             </a:xfrm>
             <a:prstGeom prst="roundRect">
@@ -5088,7 +5088,7 @@
           </p:nvSpPr>
           <p:spPr>
             <a:xfrm>
-              <a:off x="10652896" y="1594834"/>
+              <a:off x="10652896" y="1419616"/>
               <a:ext cx="628698" cy="400110"/>
             </a:xfrm>
             <a:prstGeom prst="rect">
@@ -5122,7 +5122,7 @@
           </p:nvSpPr>
           <p:spPr>
             <a:xfrm>
-              <a:off x="10138475" y="1827432"/>
+              <a:off x="10138475" y="1652214"/>
               <a:ext cx="1578637" cy="400110"/>
             </a:xfrm>
             <a:prstGeom prst="rect">
@@ -5156,7 +5156,7 @@
           </p:nvSpPr>
           <p:spPr>
             <a:xfrm>
-              <a:off x="10090953" y="2249495"/>
+              <a:off x="10090953" y="2074277"/>
               <a:ext cx="1653803" cy="617527"/>
             </a:xfrm>
             <a:prstGeom prst="roundRect">
@@ -5202,7 +5202,7 @@
           </p:nvSpPr>
           <p:spPr>
             <a:xfrm>
-              <a:off x="10098574" y="2210501"/>
+              <a:off x="10098574" y="2035283"/>
               <a:ext cx="1598515" cy="400110"/>
             </a:xfrm>
             <a:prstGeom prst="rect">
@@ -5236,7 +5236,7 @@
           </p:nvSpPr>
           <p:spPr>
             <a:xfrm>
-              <a:off x="10118452" y="2466912"/>
+              <a:off x="10118452" y="2291694"/>
               <a:ext cx="1578637" cy="400110"/>
             </a:xfrm>
             <a:prstGeom prst="rect">
@@ -5273,7 +5273,7 @@
           </p:nvCxnSpPr>
           <p:spPr>
             <a:xfrm flipV="1">
-              <a:off x="1535009" y="1414912"/>
+              <a:off x="1535009" y="1239694"/>
               <a:ext cx="228623" cy="480852"/>
             </a:xfrm>
             <a:prstGeom prst="line">
@@ -5314,7 +5314,7 @@
           </p:nvCxnSpPr>
           <p:spPr>
             <a:xfrm>
-              <a:off x="1535009" y="1895764"/>
+              <a:off x="1535009" y="1720546"/>
               <a:ext cx="228623" cy="655798"/>
             </a:xfrm>
             <a:prstGeom prst="line">
@@ -5355,7 +5355,7 @@
           </p:nvCxnSpPr>
           <p:spPr>
             <a:xfrm flipV="1">
-              <a:off x="3416660" y="1422994"/>
+              <a:off x="3416660" y="1247776"/>
               <a:ext cx="192204" cy="1014"/>
             </a:xfrm>
             <a:prstGeom prst="line">
@@ -5396,7 +5396,7 @@
           </p:nvCxnSpPr>
           <p:spPr>
             <a:xfrm flipV="1">
-              <a:off x="3432575" y="2550542"/>
+              <a:off x="3432575" y="2375324"/>
               <a:ext cx="200424" cy="1020"/>
             </a:xfrm>
             <a:prstGeom prst="line">
@@ -5437,7 +5437,7 @@
           </p:nvCxnSpPr>
           <p:spPr>
             <a:xfrm>
-              <a:off x="5053872" y="1422994"/>
+              <a:off x="5053872" y="1247776"/>
               <a:ext cx="180047" cy="430785"/>
             </a:xfrm>
             <a:prstGeom prst="line">
@@ -5478,7 +5478,7 @@
           </p:nvCxnSpPr>
           <p:spPr>
             <a:xfrm flipV="1">
-              <a:off x="5014394" y="1853779"/>
+              <a:off x="5014394" y="1678561"/>
               <a:ext cx="219525" cy="696763"/>
             </a:xfrm>
             <a:prstGeom prst="line">
@@ -5515,8 +5515,8 @@
           </p:nvSpPr>
           <p:spPr>
             <a:xfrm>
-              <a:off x="5233919" y="1068034"/>
-              <a:ext cx="2183051" cy="1571490"/>
+              <a:off x="5233919" y="664308"/>
+              <a:ext cx="2183051" cy="2028506"/>
             </a:xfrm>
             <a:prstGeom prst="roundRect">
               <a:avLst/>
@@ -5561,7 +5561,7 @@
           </p:nvSpPr>
           <p:spPr>
             <a:xfrm>
-              <a:off x="5670440" y="1114568"/>
+              <a:off x="5670440" y="729871"/>
               <a:ext cx="1329016" cy="400110"/>
             </a:xfrm>
             <a:prstGeom prst="rect">
@@ -5605,7 +5605,7 @@
               </p:nvSpPr>
               <p:spPr>
                 <a:xfrm>
-                  <a:off x="5218212" y="1468143"/>
+                  <a:off x="5233919" y="1072315"/>
                   <a:ext cx="2251577" cy="407291"/>
                 </a:xfrm>
                 <a:prstGeom prst="rect">
@@ -5821,7 +5821,7 @@
               </p:nvSpPr>
               <p:spPr>
                 <a:xfrm>
-                  <a:off x="5218212" y="1468143"/>
+                  <a:off x="5233919" y="1072315"/>
                   <a:ext cx="2251577" cy="407291"/>
                 </a:xfrm>
                 <a:prstGeom prst="rect">
@@ -5830,7 +5830,7 @@
                 <a:blipFill>
                   <a:blip r:embed="rId7"/>
                   <a:stretch>
-                    <a:fillRect b="-8955"/>
+                    <a:fillRect b="-7463"/>
                   </a:stretch>
                 </a:blipFill>
               </p:spPr>
@@ -5859,7 +5859,7 @@
               </p:nvSpPr>
               <p:spPr>
                 <a:xfrm>
-                  <a:off x="5526691" y="1855982"/>
+                  <a:off x="5556543" y="1472425"/>
                   <a:ext cx="1627177" cy="745460"/>
                 </a:xfrm>
                 <a:prstGeom prst="rect">
@@ -6164,7 +6164,7 @@
               </p:nvSpPr>
               <p:spPr>
                 <a:xfrm>
-                  <a:off x="5526691" y="1855982"/>
+                  <a:off x="5556543" y="1472425"/>
                   <a:ext cx="1627177" cy="745460"/>
                 </a:xfrm>
                 <a:prstGeom prst="rect">
@@ -6173,7 +6173,7 @@
                 <a:blipFill>
                   <a:blip r:embed="rId8"/>
                   <a:stretch>
-                    <a:fillRect l="-1124" b="-4098"/>
+                    <a:fillRect l="-1128" b="-4098"/>
                   </a:stretch>
                 </a:blipFill>
               </p:spPr>
@@ -6204,7 +6204,7 @@
           </p:nvCxnSpPr>
           <p:spPr>
             <a:xfrm>
-              <a:off x="7416970" y="1853779"/>
+              <a:off x="7416970" y="1678561"/>
               <a:ext cx="225614" cy="0"/>
             </a:xfrm>
             <a:prstGeom prst="line">
@@ -6245,7 +6245,7 @@
           </p:nvCxnSpPr>
           <p:spPr>
             <a:xfrm flipV="1">
-              <a:off x="9623979" y="1266793"/>
+              <a:off x="9623979" y="1091575"/>
               <a:ext cx="466974" cy="586986"/>
             </a:xfrm>
             <a:prstGeom prst="line">
@@ -6286,7 +6286,7 @@
           </p:nvCxnSpPr>
           <p:spPr>
             <a:xfrm>
-              <a:off x="9623979" y="1853779"/>
+              <a:off x="9623979" y="1678561"/>
               <a:ext cx="474595" cy="70203"/>
             </a:xfrm>
             <a:prstGeom prst="line">
@@ -6327,7 +6327,7 @@
           </p:nvCxnSpPr>
           <p:spPr>
             <a:xfrm>
-              <a:off x="9623979" y="1853779"/>
+              <a:off x="9623979" y="1678561"/>
               <a:ext cx="466974" cy="704480"/>
             </a:xfrm>
             <a:prstGeom prst="line">
@@ -6356,6 +6356,51 @@
             </a:fontRef>
           </p:style>
         </p:cxnSp>
+        <p:sp>
+          <p:nvSpPr>
+            <p:cNvPr id="59" name="TextBox 25">
+              <a:extLst>
+                <a:ext uri="{FF2B5EF4-FFF2-40B4-BE49-F238E27FC236}">
+                  <a16:creationId xmlns:a16="http://schemas.microsoft.com/office/drawing/2014/main" id="{54317EE6-0E41-1239-3C0B-C72D718AA343}"/>
+                </a:ext>
+              </a:extLst>
+            </p:cNvPr>
+            <p:cNvSpPr txBox="1"/>
+            <p:nvPr/>
+          </p:nvSpPr>
+          <p:spPr>
+            <a:xfrm>
+              <a:off x="5276055" y="2192127"/>
+              <a:ext cx="2199064" cy="400110"/>
+            </a:xfrm>
+            <a:prstGeom prst="rect">
+              <a:avLst/>
+            </a:prstGeom>
+            <a:noFill/>
+          </p:spPr>
+          <p:txBody>
+            <a:bodyPr wrap="none">
+              <a:spAutoFit/>
+            </a:bodyPr>
+            <a:lstStyle/>
+            <a:p>
+              <a:pPr algn="ctr"/>
+              <a:r>
+                <a:rPr lang="en-US" sz="2000" dirty="0">
+                  <a:solidFill>
+                    <a:srgbClr val="8B5CF6"/>
+                  </a:solidFill>
+                </a:rPr>
+                <a:t>+Position Encoding</a:t>
+              </a:r>
+              <a:endParaRPr sz="2000" dirty="0">
+                <a:solidFill>
+                  <a:srgbClr val="8B5CF6"/>
+                </a:solidFill>
+              </a:endParaRPr>
+            </a:p>
+          </p:txBody>
+        </p:sp>
       </p:grpSp>
     </p:spTree>
   </p:cSld>

</xml_diff>